<commit_message>
sort file and folder location
</commit_message>
<xml_diff>
--- a/1.training_model/slide_presentation/Device Identifier 20260520.pptx
+++ b/1.training_model/slide_presentation/Device Identifier 20260520.pptx
@@ -5,13 +5,15 @@
     <p:sldMasterId id="2147483696" r:id="rId1"/>
   </p:sldMasterIdLst>
   <p:notesMasterIdLst>
-    <p:notesMasterId r:id="rId6"/>
+    <p:notesMasterId r:id="rId8"/>
   </p:notesMasterIdLst>
   <p:sldIdLst>
     <p:sldId id="256" r:id="rId2"/>
     <p:sldId id="325" r:id="rId3"/>
     <p:sldId id="292" r:id="rId4"/>
     <p:sldId id="323" r:id="rId5"/>
+    <p:sldId id="327" r:id="rId6"/>
+    <p:sldId id="326" r:id="rId7"/>
   </p:sldIdLst>
   <p:sldSz cx="12192000" cy="6858000"/>
   <p:notesSz cx="6858000" cy="9144000"/>
@@ -200,7 +202,7 @@
           <a:p>
             <a:fld id="{23D8B80A-F233-4240-BDAF-6537AE249829}" type="datetimeFigureOut">
               <a:rPr lang="en-MY" smtClean="0"/>
-              <a:t>20/5/2026</a:t>
+              <a:t>21/5/2026</a:t>
             </a:fld>
             <a:endParaRPr lang="en-MY"/>
           </a:p>
@@ -744,6 +746,114 @@
 </p:notes>
 </file>
 
+<file path=ppt/notesSlides/notesSlide4.xml><?xml version="1.0" encoding="utf-8"?>
+<p:notes xmlns:a="http://schemas.openxmlformats.org/drawingml/2006/main" xmlns:r="http://schemas.openxmlformats.org/officeDocument/2006/relationships" xmlns:p="http://schemas.openxmlformats.org/presentationml/2006/main">
+  <p:cSld>
+    <p:spTree>
+      <p:nvGrpSpPr>
+        <p:cNvPr id="1" name="">
+          <a:extLst>
+            <a:ext uri="{FF2B5EF4-FFF2-40B4-BE49-F238E27FC236}">
+              <a16:creationId xmlns:a16="http://schemas.microsoft.com/office/drawing/2014/main" id="{E96BB1E2-2CB1-5021-75E5-CF6CCD57DE06}"/>
+            </a:ext>
+          </a:extLst>
+        </p:cNvPr>
+        <p:cNvGrpSpPr/>
+        <p:nvPr/>
+      </p:nvGrpSpPr>
+      <p:grpSpPr>
+        <a:xfrm>
+          <a:off x="0" y="0"/>
+          <a:ext cx="0" cy="0"/>
+          <a:chOff x="0" y="0"/>
+          <a:chExt cx="0" cy="0"/>
+        </a:xfrm>
+      </p:grpSpPr>
+      <p:sp>
+        <p:nvSpPr>
+          <p:cNvPr id="2" name="Slide Image Placeholder 1">
+            <a:extLst>
+              <a:ext uri="{FF2B5EF4-FFF2-40B4-BE49-F238E27FC236}">
+                <a16:creationId xmlns:a16="http://schemas.microsoft.com/office/drawing/2014/main" id="{1B700753-6D9B-7CA5-2453-C8409535183B}"/>
+              </a:ext>
+            </a:extLst>
+          </p:cNvPr>
+          <p:cNvSpPr>
+            <a:spLocks noGrp="1" noRot="1" noChangeAspect="1"/>
+          </p:cNvSpPr>
+          <p:nvPr>
+            <p:ph type="sldImg"/>
+          </p:nvPr>
+        </p:nvSpPr>
+        <p:spPr/>
+      </p:sp>
+      <p:sp>
+        <p:nvSpPr>
+          <p:cNvPr id="3" name="Notes Placeholder 2">
+            <a:extLst>
+              <a:ext uri="{FF2B5EF4-FFF2-40B4-BE49-F238E27FC236}">
+                <a16:creationId xmlns:a16="http://schemas.microsoft.com/office/drawing/2014/main" id="{40D44659-0B80-A575-79ED-8829A738DBDB}"/>
+              </a:ext>
+            </a:extLst>
+          </p:cNvPr>
+          <p:cNvSpPr>
+            <a:spLocks noGrp="1"/>
+          </p:cNvSpPr>
+          <p:nvPr>
+            <p:ph type="body" idx="1"/>
+          </p:nvPr>
+        </p:nvSpPr>
+        <p:spPr/>
+        <p:txBody>
+          <a:bodyPr/>
+          <a:lstStyle/>
+          <a:p>
+            <a:endParaRPr lang="en-MY" dirty="0"/>
+          </a:p>
+        </p:txBody>
+      </p:sp>
+      <p:sp>
+        <p:nvSpPr>
+          <p:cNvPr id="4" name="Slide Number Placeholder 3">
+            <a:extLst>
+              <a:ext uri="{FF2B5EF4-FFF2-40B4-BE49-F238E27FC236}">
+                <a16:creationId xmlns:a16="http://schemas.microsoft.com/office/drawing/2014/main" id="{C33108B5-6282-34C4-DE56-EADE451903FF}"/>
+              </a:ext>
+            </a:extLst>
+          </p:cNvPr>
+          <p:cNvSpPr>
+            <a:spLocks noGrp="1"/>
+          </p:cNvSpPr>
+          <p:nvPr>
+            <p:ph type="sldNum" sz="quarter" idx="5"/>
+          </p:nvPr>
+        </p:nvSpPr>
+        <p:spPr/>
+        <p:txBody>
+          <a:bodyPr/>
+          <a:lstStyle/>
+          <a:p>
+            <a:fld id="{D16833E0-5E66-4D1D-89F5-BD860FDD8F71}" type="slidenum">
+              <a:rPr lang="en-MY" smtClean="0"/>
+              <a:t>5</a:t>
+            </a:fld>
+            <a:endParaRPr lang="en-MY"/>
+          </a:p>
+        </p:txBody>
+      </p:sp>
+    </p:spTree>
+    <p:extLst>
+      <p:ext uri="{BB962C8B-B14F-4D97-AF65-F5344CB8AC3E}">
+        <p14:creationId xmlns:p14="http://schemas.microsoft.com/office/powerpoint/2010/main" val="127372749"/>
+      </p:ext>
+    </p:extLst>
+  </p:cSld>
+  <p:clrMapOvr>
+    <a:masterClrMapping/>
+  </p:clrMapOvr>
+</p:notes>
+</file>
+
 <file path=ppt/slideLayouts/slideLayout1.xml><?xml version="1.0" encoding="utf-8"?>
 <p:sldLayout xmlns:a="http://schemas.openxmlformats.org/drawingml/2006/main" xmlns:r="http://schemas.openxmlformats.org/officeDocument/2006/relationships" xmlns:p="http://schemas.openxmlformats.org/presentationml/2006/main" type="title" preserve="1">
   <p:cSld name="Title Slide">
@@ -915,7 +1025,7 @@
           <a:p>
             <a:fld id="{1CD01395-AC05-405C-BAB9-E5D2B9FDBB40}" type="datetimeFigureOut">
               <a:rPr lang="en-MY" smtClean="0"/>
-              <a:t>20/5/2026</a:t>
+              <a:t>21/5/2026</a:t>
             </a:fld>
             <a:endParaRPr lang="en-MY"/>
           </a:p>
@@ -1230,7 +1340,7 @@
           <a:p>
             <a:fld id="{1CD01395-AC05-405C-BAB9-E5D2B9FDBB40}" type="datetimeFigureOut">
               <a:rPr lang="en-MY" smtClean="0"/>
-              <a:t>20/5/2026</a:t>
+              <a:t>21/5/2026</a:t>
             </a:fld>
             <a:endParaRPr lang="en-MY"/>
           </a:p>
@@ -1452,7 +1562,7 @@
           <a:p>
             <a:fld id="{1CD01395-AC05-405C-BAB9-E5D2B9FDBB40}" type="datetimeFigureOut">
               <a:rPr lang="en-MY" smtClean="0"/>
-              <a:t>20/5/2026</a:t>
+              <a:t>21/5/2026</a:t>
             </a:fld>
             <a:endParaRPr lang="en-MY"/>
           </a:p>
@@ -1743,7 +1853,7 @@
           <a:p>
             <a:fld id="{1CD01395-AC05-405C-BAB9-E5D2B9FDBB40}" type="datetimeFigureOut">
               <a:rPr lang="en-MY" smtClean="0"/>
-              <a:t>20/5/2026</a:t>
+              <a:t>21/5/2026</a:t>
             </a:fld>
             <a:endParaRPr lang="en-MY"/>
           </a:p>
@@ -2197,7 +2307,7 @@
           <a:p>
             <a:fld id="{1CD01395-AC05-405C-BAB9-E5D2B9FDBB40}" type="datetimeFigureOut">
               <a:rPr lang="en-MY" smtClean="0"/>
-              <a:t>20/5/2026</a:t>
+              <a:t>21/5/2026</a:t>
             </a:fld>
             <a:endParaRPr lang="en-MY"/>
           </a:p>
@@ -2773,7 +2883,7 @@
           <a:p>
             <a:fld id="{1CD01395-AC05-405C-BAB9-E5D2B9FDBB40}" type="datetimeFigureOut">
               <a:rPr lang="en-MY" smtClean="0"/>
-              <a:t>20/5/2026</a:t>
+              <a:t>21/5/2026</a:t>
             </a:fld>
             <a:endParaRPr lang="en-MY"/>
           </a:p>
@@ -3634,7 +3744,7 @@
           <a:p>
             <a:fld id="{1CD01395-AC05-405C-BAB9-E5D2B9FDBB40}" type="datetimeFigureOut">
               <a:rPr lang="en-MY" smtClean="0"/>
-              <a:t>20/5/2026</a:t>
+              <a:t>21/5/2026</a:t>
             </a:fld>
             <a:endParaRPr lang="en-MY"/>
           </a:p>
@@ -3839,7 +3949,7 @@
           <a:p>
             <a:fld id="{1CD01395-AC05-405C-BAB9-E5D2B9FDBB40}" type="datetimeFigureOut">
               <a:rPr lang="en-MY" smtClean="0"/>
-              <a:t>20/5/2026</a:t>
+              <a:t>21/5/2026</a:t>
             </a:fld>
             <a:endParaRPr lang="en-MY"/>
           </a:p>
@@ -4053,7 +4163,7 @@
           <a:p>
             <a:fld id="{1CD01395-AC05-405C-BAB9-E5D2B9FDBB40}" type="datetimeFigureOut">
               <a:rPr lang="en-MY" smtClean="0"/>
-              <a:t>20/5/2026</a:t>
+              <a:t>21/5/2026</a:t>
             </a:fld>
             <a:endParaRPr lang="en-MY"/>
           </a:p>
@@ -4258,7 +4368,7 @@
           <a:p>
             <a:fld id="{1CD01395-AC05-405C-BAB9-E5D2B9FDBB40}" type="datetimeFigureOut">
               <a:rPr lang="en-MY" smtClean="0"/>
-              <a:t>20/5/2026</a:t>
+              <a:t>21/5/2026</a:t>
             </a:fld>
             <a:endParaRPr lang="en-MY"/>
           </a:p>
@@ -4538,7 +4648,7 @@
           <a:p>
             <a:fld id="{1CD01395-AC05-405C-BAB9-E5D2B9FDBB40}" type="datetimeFigureOut">
               <a:rPr lang="en-MY" smtClean="0"/>
-              <a:t>20/5/2026</a:t>
+              <a:t>21/5/2026</a:t>
             </a:fld>
             <a:endParaRPr lang="en-MY"/>
           </a:p>
@@ -4805,7 +4915,7 @@
           <a:p>
             <a:fld id="{1CD01395-AC05-405C-BAB9-E5D2B9FDBB40}" type="datetimeFigureOut">
               <a:rPr lang="en-MY" smtClean="0"/>
-              <a:t>20/5/2026</a:t>
+              <a:t>21/5/2026</a:t>
             </a:fld>
             <a:endParaRPr lang="en-MY"/>
           </a:p>
@@ -5220,7 +5330,7 @@
           <a:p>
             <a:fld id="{1CD01395-AC05-405C-BAB9-E5D2B9FDBB40}" type="datetimeFigureOut">
               <a:rPr lang="en-MY" smtClean="0"/>
-              <a:t>20/5/2026</a:t>
+              <a:t>21/5/2026</a:t>
             </a:fld>
             <a:endParaRPr lang="en-MY"/>
           </a:p>
@@ -5368,7 +5478,7 @@
           <a:p>
             <a:fld id="{1CD01395-AC05-405C-BAB9-E5D2B9FDBB40}" type="datetimeFigureOut">
               <a:rPr lang="en-MY" smtClean="0"/>
-              <a:t>20/5/2026</a:t>
+              <a:t>21/5/2026</a:t>
             </a:fld>
             <a:endParaRPr lang="en-MY"/>
           </a:p>
@@ -5493,7 +5603,7 @@
           <a:p>
             <a:fld id="{1CD01395-AC05-405C-BAB9-E5D2B9FDBB40}" type="datetimeFigureOut">
               <a:rPr lang="en-MY" smtClean="0"/>
-              <a:t>20/5/2026</a:t>
+              <a:t>21/5/2026</a:t>
             </a:fld>
             <a:endParaRPr lang="en-MY"/>
           </a:p>
@@ -5772,7 +5882,7 @@
           <a:p>
             <a:fld id="{1CD01395-AC05-405C-BAB9-E5D2B9FDBB40}" type="datetimeFigureOut">
               <a:rPr lang="en-MY" smtClean="0"/>
-              <a:t>20/5/2026</a:t>
+              <a:t>21/5/2026</a:t>
             </a:fld>
             <a:endParaRPr lang="en-MY"/>
           </a:p>
@@ -6087,7 +6197,7 @@
           <a:p>
             <a:fld id="{1CD01395-AC05-405C-BAB9-E5D2B9FDBB40}" type="datetimeFigureOut">
               <a:rPr lang="en-MY" smtClean="0"/>
-              <a:t>20/5/2026</a:t>
+              <a:t>21/5/2026</a:t>
             </a:fld>
             <a:endParaRPr lang="en-MY"/>
           </a:p>
@@ -6340,7 +6450,7 @@
           <a:p>
             <a:fld id="{1CD01395-AC05-405C-BAB9-E5D2B9FDBB40}" type="datetimeFigureOut">
               <a:rPr lang="en-MY" smtClean="0"/>
-              <a:t>20/5/2026</a:t>
+              <a:t>21/5/2026</a:t>
             </a:fld>
             <a:endParaRPr lang="en-MY"/>
           </a:p>
@@ -10667,6 +10777,165 @@
     <p:extLst>
       <p:ext uri="{BB962C8B-B14F-4D97-AF65-F5344CB8AC3E}">
         <p14:creationId xmlns:p14="http://schemas.microsoft.com/office/powerpoint/2010/main" val="16583078"/>
+      </p:ext>
+    </p:extLst>
+  </p:cSld>
+  <p:clrMapOvr>
+    <a:masterClrMapping/>
+  </p:clrMapOvr>
+</p:sld>
+</file>
+
+<file path=ppt/slides/slide5.xml><?xml version="1.0" encoding="utf-8"?>
+<p:sld xmlns:a="http://schemas.openxmlformats.org/drawingml/2006/main" xmlns:r="http://schemas.openxmlformats.org/officeDocument/2006/relationships" xmlns:p="http://schemas.openxmlformats.org/presentationml/2006/main" showMasterSp="0">
+  <p:cSld>
+    <p:bg>
+      <p:bgPr>
+        <a:solidFill>
+          <a:srgbClr val="CDF6F9"/>
+        </a:solidFill>
+        <a:effectLst/>
+      </p:bgPr>
+    </p:bg>
+    <p:spTree>
+      <p:nvGrpSpPr>
+        <p:cNvPr id="1" name="">
+          <a:extLst>
+            <a:ext uri="{FF2B5EF4-FFF2-40B4-BE49-F238E27FC236}">
+              <a16:creationId xmlns:a16="http://schemas.microsoft.com/office/drawing/2014/main" id="{700F46A2-011D-3546-0B8A-E87BD8F1A4B0}"/>
+            </a:ext>
+          </a:extLst>
+        </p:cNvPr>
+        <p:cNvGrpSpPr/>
+        <p:nvPr/>
+      </p:nvGrpSpPr>
+      <p:grpSpPr>
+        <a:xfrm>
+          <a:off x="0" y="0"/>
+          <a:ext cx="0" cy="0"/>
+          <a:chOff x="0" y="0"/>
+          <a:chExt cx="0" cy="0"/>
+        </a:xfrm>
+      </p:grpSpPr>
+      <p:sp>
+        <p:nvSpPr>
+          <p:cNvPr id="2" name="TextBox 1">
+            <a:extLst>
+              <a:ext uri="{FF2B5EF4-FFF2-40B4-BE49-F238E27FC236}">
+                <a16:creationId xmlns:a16="http://schemas.microsoft.com/office/drawing/2014/main" id="{D2532F23-4670-2ED4-3919-B3B8454E3933}"/>
+              </a:ext>
+            </a:extLst>
+          </p:cNvPr>
+          <p:cNvSpPr txBox="1"/>
+          <p:nvPr/>
+        </p:nvSpPr>
+        <p:spPr>
+          <a:xfrm>
+            <a:off x="4504451" y="960120"/>
+            <a:ext cx="3036793" cy="369332"/>
+          </a:xfrm>
+          <a:prstGeom prst="rect">
+            <a:avLst/>
+          </a:prstGeom>
+          <a:noFill/>
+        </p:spPr>
+        <p:txBody>
+          <a:bodyPr wrap="none" rtlCol="0">
+            <a:spAutoFit/>
+          </a:bodyPr>
+          <a:lstStyle/>
+          <a:p>
+            <a:r>
+              <a:rPr lang="en-US" dirty="0"/>
+              <a:t>HOW TO SORT THE PROJECT?</a:t>
+            </a:r>
+          </a:p>
+        </p:txBody>
+      </p:sp>
+    </p:spTree>
+    <p:extLst>
+      <p:ext uri="{BB962C8B-B14F-4D97-AF65-F5344CB8AC3E}">
+        <p14:creationId xmlns:p14="http://schemas.microsoft.com/office/powerpoint/2010/main" val="975718132"/>
+      </p:ext>
+    </p:extLst>
+  </p:cSld>
+  <p:clrMapOvr>
+    <a:masterClrMapping/>
+  </p:clrMapOvr>
+</p:sld>
+</file>
+
+<file path=ppt/slides/slide6.xml><?xml version="1.0" encoding="utf-8"?>
+<p:sld xmlns:a="http://schemas.openxmlformats.org/drawingml/2006/main" xmlns:r="http://schemas.openxmlformats.org/officeDocument/2006/relationships" xmlns:p="http://schemas.openxmlformats.org/presentationml/2006/main">
+  <p:cSld>
+    <p:spTree>
+      <p:nvGrpSpPr>
+        <p:cNvPr id="1" name=""/>
+        <p:cNvGrpSpPr/>
+        <p:nvPr/>
+      </p:nvGrpSpPr>
+      <p:grpSpPr>
+        <a:xfrm>
+          <a:off x="0" y="0"/>
+          <a:ext cx="0" cy="0"/>
+          <a:chOff x="0" y="0"/>
+          <a:chExt cx="0" cy="0"/>
+        </a:xfrm>
+      </p:grpSpPr>
+      <p:sp>
+        <p:nvSpPr>
+          <p:cNvPr id="2" name="Title 1">
+            <a:extLst>
+              <a:ext uri="{FF2B5EF4-FFF2-40B4-BE49-F238E27FC236}">
+                <a16:creationId xmlns:a16="http://schemas.microsoft.com/office/drawing/2014/main" id="{887D954D-6BAB-E5BB-EDE6-E99E9E8B7146}"/>
+              </a:ext>
+            </a:extLst>
+          </p:cNvPr>
+          <p:cNvSpPr>
+            <a:spLocks noGrp="1"/>
+          </p:cNvSpPr>
+          <p:nvPr>
+            <p:ph type="title"/>
+          </p:nvPr>
+        </p:nvSpPr>
+        <p:spPr/>
+        <p:txBody>
+          <a:bodyPr/>
+          <a:lstStyle/>
+          <a:p>
+            <a:endParaRPr lang="en-MY"/>
+          </a:p>
+        </p:txBody>
+      </p:sp>
+      <p:sp>
+        <p:nvSpPr>
+          <p:cNvPr id="3" name="Content Placeholder 2">
+            <a:extLst>
+              <a:ext uri="{FF2B5EF4-FFF2-40B4-BE49-F238E27FC236}">
+                <a16:creationId xmlns:a16="http://schemas.microsoft.com/office/drawing/2014/main" id="{E3051F36-2B91-1D55-6FDC-91FFF40B05A1}"/>
+              </a:ext>
+            </a:extLst>
+          </p:cNvPr>
+          <p:cNvSpPr>
+            <a:spLocks noGrp="1"/>
+          </p:cNvSpPr>
+          <p:nvPr>
+            <p:ph sz="quarter" idx="13"/>
+          </p:nvPr>
+        </p:nvSpPr>
+        <p:spPr/>
+        <p:txBody>
+          <a:bodyPr/>
+          <a:lstStyle/>
+          <a:p>
+            <a:endParaRPr lang="en-MY"/>
+          </a:p>
+        </p:txBody>
+      </p:sp>
+    </p:spTree>
+    <p:extLst>
+      <p:ext uri="{BB962C8B-B14F-4D97-AF65-F5344CB8AC3E}">
+        <p14:creationId xmlns:p14="http://schemas.microsoft.com/office/powerpoint/2010/main" val="1573312710"/>
       </p:ext>
     </p:extLst>
   </p:cSld>

</xml_diff>